<commit_message>
Sync US 114051 PPTX with the fixed PDF cover layout
Meta labels on the cover render on a single line (wrap: false,
tighter character spacing) so they cannot overlap their values,
even when PowerPoint substitutes fonts. Regenerated the PPTX —
15 slides matching the PDF deck exactly.

Co-authored-by: Copilot <223556219+Copilot@users.noreply.github.com>
</commit_message>
<xml_diff>
--- a/public/downloads/US-114051-Technical-Practitioners-Meeting.pptx
+++ b/public/downloads/US-114051-Technical-Practitioners-Meeting.pptx
@@ -2354,14 +2354,14 @@
           <a:ln/>
         </p:spPr>
         <p:txBody>
-          <a:bodyPr wrap="square" rtlCol="0" anchor="ctr"/>
+          <a:bodyPr wrap="none" rtlCol="0" anchor="ctr"/>
           <a:lstStyle/>
           <a:p>
             <a:pPr indent="0" marL="0">
               <a:buNone/>
             </a:pPr>
             <a:r>
-              <a:rPr lang="en-US" sz="1800" b="1" spc="100" kern="0" dirty="0">
+              <a:rPr lang="en-US" sz="1800" b="1" spc="50" kern="0" dirty="0">
                 <a:solidFill>
                   <a:srgbClr val="0F6CBD"/>
                 </a:solidFill>
@@ -2435,14 +2435,14 @@
           <a:ln/>
         </p:spPr>
         <p:txBody>
-          <a:bodyPr wrap="square" rtlCol="0" anchor="ctr"/>
+          <a:bodyPr wrap="none" rtlCol="0" anchor="ctr"/>
           <a:lstStyle/>
           <a:p>
             <a:pPr indent="0" marL="0">
               <a:buNone/>
             </a:pPr>
             <a:r>
-              <a:rPr lang="en-US" sz="1800" b="1" spc="100" kern="0" dirty="0">
+              <a:rPr lang="en-US" sz="1800" b="1" spc="50" kern="0" dirty="0">
                 <a:solidFill>
                   <a:srgbClr val="0F6CBD"/>
                 </a:solidFill>
@@ -2516,14 +2516,14 @@
           <a:ln/>
         </p:spPr>
         <p:txBody>
-          <a:bodyPr wrap="square" rtlCol="0" anchor="ctr"/>
+          <a:bodyPr wrap="none" rtlCol="0" anchor="ctr"/>
           <a:lstStyle/>
           <a:p>
             <a:pPr indent="0" marL="0">
               <a:buNone/>
             </a:pPr>
             <a:r>
-              <a:rPr lang="en-US" sz="1800" b="1" spc="100" kern="0" dirty="0">
+              <a:rPr lang="en-US" sz="1800" b="1" spc="50" kern="0" dirty="0">
                 <a:solidFill>
                   <a:srgbClr val="0F6CBD"/>
                 </a:solidFill>
@@ -2597,14 +2597,14 @@
           <a:ln/>
         </p:spPr>
         <p:txBody>
-          <a:bodyPr wrap="square" rtlCol="0" anchor="ctr"/>
+          <a:bodyPr wrap="none" rtlCol="0" anchor="ctr"/>
           <a:lstStyle/>
           <a:p>
             <a:pPr indent="0" marL="0">
               <a:buNone/>
             </a:pPr>
             <a:r>
-              <a:rPr lang="en-US" sz="1800" b="1" spc="100" kern="0" dirty="0">
+              <a:rPr lang="en-US" sz="1800" b="1" spc="50" kern="0" dirty="0">
                 <a:solidFill>
                   <a:srgbClr val="0F6CBD"/>
                 </a:solidFill>

</xml_diff>